<commit_message>
Move every web and email address to crossroadsweddingco.shop
The .com domain is abandoned. SITE_URL falls back to .shop (canonicals,
sitemap, JSON-LD, hub and email links, Spotify redirect URI), all
addresses in lib/site.ts and lib/schedulers.ts are @crossroadsweddingco.shop,
and the partner deck, storefront slide 07 and the acoustic and bartending
reels are regenerated with the new address.

Co-Authored-By: Claude Opus 5.5 <noreply@anthropic.com>
Claude-Session: https://claude.ai/code/session_01XnH6ahBeWCivrLHTaCcBN4
</commit_message>
<xml_diff>
--- a/content/partner/crossroads-partner-brief-nic.pptx
+++ b/content/partner/crossroads-partner-brief-nic.pptx
@@ -5188,7 +5188,7 @@
                 <a:ea typeface="Calibri" pitchFamily="34" charset="-122"/>
                 <a:cs typeface="Calibri" pitchFamily="34" charset="-120"/>
               </a:rPr>
-              <a:t>Flat-rate site, date requests, deposits, confirmation emails. Live today at crossroadsweddingco.com.</a:t>
+              <a:t>Flat-rate site, date requests, deposits, confirmation emails. Live today at crossroadsweddingco.shop.</a:t>
             </a:r>
             <a:endParaRPr lang="en-US" sz="1200" dirty="0"/>
           </a:p>
@@ -6809,7 +6809,7 @@
                 <a:ea typeface="Calibri" pitchFamily="34" charset="-122"/>
                 <a:cs typeface="Calibri" pitchFamily="34" charset="-120"/>
               </a:rPr>
-              <a:t>Jacob Kennedy · jake@crossroadsweddingco.com · crossroadsweddingco.com</a:t>
+              <a:t>Jacob Kennedy · jake@crossroadsweddingco.shop · crossroadsweddingco.shop</a:t>
             </a:r>
             <a:endParaRPr lang="en-US" sz="1200" dirty="0"/>
           </a:p>

</xml_diff>